<commit_message>
docs: robust mask, contrast stretch, correction of the size-feature effect
- experiments.md: new entry 2026-10-29 with all render runs so far, the
  contrast experiment and a placeholder table for the seed runs
- correction: baseline runs of the same config differ by up to 34 length
  errors, so the -39 % for the size feature compared against the worst run
- slides: slide 6 shows all baseline runs vs the size feature, seed table to
  be filled in; small fixes on slides 2 and 7

Co-Authored-By: Claude Opus 5.5 <noreply@anthropic.com>
Claude-Session: https://claude.ai/code/session_016ynpjMZGN2P6wMb6kjy8nN
</commit_message>
<xml_diff>
--- a/docs/presentations/2026-10-23_progress_shape_v0.pptx
+++ b/docs/presentations/2026-10-23_progress_shape_v0.pptx
@@ -113,25 +113,25 @@
   <p:extLst>
     <p:ext uri="{521415D9-36F7-43E2-AB2F-B90AF26B5E84}">
       <p14:sectionLst xmlns:p14="http://schemas.microsoft.com/office/powerpoint/2010/main">
-        <p14:section name="Intro" id="{b2890869-46ad-bb02-70fd-2c190978498a}">
+        <p14:section name="Intro" id="{f6bce8f0-2bb2-61ed-ff4a-43c9b0d81e0c}">
           <p14:sldIdLst>
             <p14:sldId id="256"/>
           </p14:sldIdLst>
         </p14:section>
-        <p14:section name="Setup and baseline" id="{3df84820-bd91-9379-5a10-1afd019b1efe}">
+        <p14:section name="Setup and baseline" id="{6f33a436-d3e5-1b1c-2bd9-ca5f7c71af3f}">
           <p14:sldIdLst>
             <p14:sldId id="257"/>
             <p14:sldId id="258"/>
           </p14:sldIdLst>
         </p14:section>
-        <p14:section name="Error analysis" id="{a138ea59-9b1e-45c2-ec32-480401f014c2}">
+        <p14:section name="Error analysis" id="{3374d702-c2e2-0bca-432a-c663ae25fc18}">
           <p14:sldIdLst>
             <p14:sldId id="259"/>
             <p14:sldId id="260"/>
             <p14:sldId id="261"/>
           </p14:sldIdLst>
         </p14:section>
-        <p14:section name="Next steps" id="{792c7912-3e7d-ba4d-19d8-5375b385b47b}">
+        <p14:section name="Next steps" id="{17c028b5-114b-3492-1be0-9fe58fd0a513}">
           <p14:sldIdLst>
             <p14:sldId id="262"/>
           </p14:sldIdLst>
@@ -524,7 +524,7 @@
       <c:layout/>
       <c:barChart>
         <c:barDir val="col"/>
-        <c:grouping val="clustered"/>
+        <c:grouping val="stacked"/>
         <c:varyColors val="0"/>
         <c:ser>
           <c:idx val="0"/>
@@ -535,7 +535,7 @@
               <c:strCache>
                 <c:ptCount val="1"/>
                 <c:pt idx="0">
-                  <c:v>Without size</c:v>
+                  <c:v>Baseline (same config, 3 runs)</c:v>
                 </c:pt>
               </c:strCache>
             </c:strRef>
@@ -548,7 +548,7 @@
           </c:spPr>
           <c:invertIfNegative val="0"/>
           <c:dLbls>
-            <c:numFmt formatCode="#,##0" sourceLinked="0"/>
+            <c:numFmt formatCode="0;;;" sourceLinked="0"/>
             <c:txPr>
               <a:bodyPr/>
               <a:lstStyle/>
@@ -556,13 +556,14 @@
                 <a:pPr>
                   <a:defRPr b="1" i="0" strike="noStrike" sz="1200" u="none">
                     <a:solidFill>
-                      <a:srgbClr val="1E2530"/>
+                      <a:srgbClr val="FFFFFF"/>
                     </a:solidFill>
                     <a:latin typeface="+mn-lt"/>
                   </a:defRPr>
                 </a:pPr>
               </a:p>
             </c:txPr>
+            <c:dLblPos val="inEnd"/>
             <c:showLegendKey val="0"/>
             <c:showVal val="1"/>
             <c:showCatName val="0"/>
@@ -573,15 +574,21 @@
           </c:dLbls>
           <c:cat>
             <c:multiLvlStrRef>
-              <c:f>Sheet1!$A$2:$A$3</c:f>
+              <c:f>Sheet1!$A$2:$A$5</c:f>
               <c:multiLvlStrCache>
-                <c:ptCount val="2"/>
+                <c:ptCount val="4"/>
                 <c:lvl>
                   <c:pt idx="0">
-                    <c:v>Length / size errors</c:v>
+                    <c:v>Baseline run A</c:v>
                   </c:pt>
                   <c:pt idx="1">
-                    <c:v>All other errors</c:v>
+                    <c:v>Baseline run B</c:v>
+                  </c:pt>
+                  <c:pt idx="2">
+                    <c:v>Baseline run C</c:v>
+                  </c:pt>
+                  <c:pt idx="3">
+                    <c:v>With size</c:v>
                   </c:pt>
                 </c:lvl>
               </c:multiLvlStrCache>
@@ -589,15 +596,21 @@
           </c:cat>
           <c:val>
             <c:numRef>
-              <c:f>Sheet1!$B$2:$B$3</c:f>
+              <c:f>Sheet1!$B$2:$B$5</c:f>
               <c:numCache>
                 <c:formatCode>General</c:formatCode>
-                <c:ptCount val="2"/>
+                <c:ptCount val="4"/>
                 <c:pt idx="0">
                   <c:v>115</c:v>
                 </c:pt>
                 <c:pt idx="1">
-                  <c:v>137</c:v>
+                  <c:v>81</c:v>
+                </c:pt>
+                <c:pt idx="2">
+                  <c:v>83</c:v>
+                </c:pt>
+                <c:pt idx="3">
+                  <c:v>0</c:v>
                 </c:pt>
               </c:numCache>
             </c:numRef>
@@ -612,7 +625,7 @@
               <c:strCache>
                 <c:ptCount val="1"/>
                 <c:pt idx="0">
-                  <c:v>With size</c:v>
+                  <c:v>With size (1 run)</c:v>
                 </c:pt>
               </c:strCache>
             </c:strRef>
@@ -625,7 +638,7 @@
           </c:spPr>
           <c:invertIfNegative val="0"/>
           <c:dLbls>
-            <c:numFmt formatCode="#,##0" sourceLinked="0"/>
+            <c:numFmt formatCode="0;;;" sourceLinked="0"/>
             <c:txPr>
               <a:bodyPr/>
               <a:lstStyle/>
@@ -633,13 +646,14 @@
                 <a:pPr>
                   <a:defRPr b="1" i="0" strike="noStrike" sz="1200" u="none">
                     <a:solidFill>
-                      <a:srgbClr val="1E2530"/>
+                      <a:srgbClr val="FFFFFF"/>
                     </a:solidFill>
                     <a:latin typeface="+mn-lt"/>
                   </a:defRPr>
                 </a:pPr>
               </a:p>
             </c:txPr>
+            <c:dLblPos val="inEnd"/>
             <c:showLegendKey val="0"/>
             <c:showVal val="1"/>
             <c:showCatName val="0"/>
@@ -650,15 +664,21 @@
           </c:dLbls>
           <c:cat>
             <c:multiLvlStrRef>
-              <c:f>Sheet1!$A$2:$A$3</c:f>
+              <c:f>Sheet1!$A$2:$A$5</c:f>
               <c:multiLvlStrCache>
-                <c:ptCount val="2"/>
+                <c:ptCount val="4"/>
                 <c:lvl>
                   <c:pt idx="0">
-                    <c:v>Length / size errors</c:v>
+                    <c:v>Baseline run A</c:v>
                   </c:pt>
                   <c:pt idx="1">
-                    <c:v>All other errors</c:v>
+                    <c:v>Baseline run B</c:v>
+                  </c:pt>
+                  <c:pt idx="2">
+                    <c:v>Baseline run C</c:v>
+                  </c:pt>
+                  <c:pt idx="3">
+                    <c:v>With size</c:v>
                   </c:pt>
                 </c:lvl>
               </c:multiLvlStrCache>
@@ -666,22 +686,28 @@
           </c:cat>
           <c:val>
             <c:numRef>
-              <c:f>Sheet1!$C$2:$C$3</c:f>
+              <c:f>Sheet1!$C$2:$C$5</c:f>
               <c:numCache>
                 <c:formatCode>General</c:formatCode>
-                <c:ptCount val="2"/>
+                <c:ptCount val="4"/>
                 <c:pt idx="0">
-                  <c:v>70</c:v>
+                  <c:v>0</c:v>
                 </c:pt>
                 <c:pt idx="1">
-                  <c:v>138</c:v>
+                  <c:v>0</c:v>
+                </c:pt>
+                <c:pt idx="2">
+                  <c:v>0</c:v>
+                </c:pt>
+                <c:pt idx="3">
+                  <c:v>70</c:v>
                 </c:pt>
               </c:numCache>
             </c:numRef>
           </c:val>
         </c:ser>
         <c:dLbls>
-          <c:numFmt formatCode="#,##0" sourceLinked="0"/>
+          <c:numFmt formatCode="0;;;" sourceLinked="0"/>
           <c:txPr>
             <a:bodyPr/>
             <a:lstStyle/>
@@ -689,13 +715,14 @@
               <a:pPr>
                 <a:defRPr b="1" i="0" strike="noStrike" sz="1200" u="none">
                   <a:solidFill>
-                    <a:srgbClr val="1E2530"/>
+                    <a:srgbClr val="FFFFFF"/>
                   </a:solidFill>
                   <a:latin typeface="+mn-lt"/>
                 </a:defRPr>
               </a:pPr>
             </a:p>
           </c:txPr>
+          <c:dLblPos val="inEnd"/>
           <c:showLegendKey val="0"/>
           <c:showVal val="1"/>
           <c:showCatName val="0"/>
@@ -704,8 +731,8 @@
           <c:showBubbleSize val="0"/>
           <c:showLeaderLines val="0"/>
         </c:dLbls>
-        <c:gapWidth val="70"/>
-        <c:overlap val="0"/>
+        <c:gapWidth val="55"/>
+        <c:overlap val="100"/>
         <c:axId val="2094734554"/>
         <c:axId val="2094734552"/>
         <c:axId val="2094734556"/>
@@ -735,7 +762,7 @@
           <a:lstStyle/>
           <a:p>
             <a:pPr>
-              <a:defRPr sz="1200" b="0" i="0" u="none" strike="noStrike">
+              <a:defRPr sz="1100" b="0" i="0" u="none" strike="noStrike">
                 <a:solidFill>
                   <a:srgbClr val="1E2530"/>
                 </a:solidFill>
@@ -755,7 +782,7 @@
         <c:axId val="2094734552"/>
         <c:scaling>
           <c:orientation val="minMax"/>
-          <c:max val="160"/>
+          <c:max val="125"/>
         </c:scaling>
         <c:delete val="1"/>
         <c:axPos val="l"/>
@@ -800,14 +827,14 @@
       </c:spPr>
     </c:plotArea>
     <c:legend>
-      <c:legendPos val="t"/>
+      <c:legendPos val="b"/>
       <c:overlay val="0"/>
       <c:txPr>
         <a:bodyPr/>
         <a:lstStyle/>
         <a:p>
           <a:pPr>
-            <a:defRPr sz="1100">
+            <a:defRPr sz="1000">
               <a:solidFill>
                 <a:srgbClr val="1E2530"/>
               </a:solidFill>
@@ -1670,7 +1697,7 @@
           <a:p>
             <a:r>
               <a:rPr lang="en-US" dirty="0"/>
-              <a:t>We kept the cropped image, so no details are lost, and gave the network the measured brick size as one extra number. During training we add about five percent noise to that number, because we will never measure size perfectly on real photos. The result: length errors drop from 115 to 70, minus 39 percent. All other errors stay exactly where they were, 137 versus 138. That second bar is our control: the change helps exactly where the hypothesis says it should, and nowhere else. Overall top-1 goes from 93.7 to 94.8 percent. This is one run per variant, so we will repeat it with more seeds.</a:t>
+              <a:t>We kept the cropped image and gave the network the measured brick size as one extra number, with about five percent noise during training. In our first comparison, length errors dropped from 115 to 70. But when we retrained the baseline with exactly the same settings, it made 81 and 83 length errors. So runs of the same configuration differ by up to 34 errors, and our first baseline was simply an unlucky run. Against the newer baselines the size feature still helps, but the effect is closer to 15 percent than to 40. That is why we now train every configuration with several seeds and report the mean and the range. The table on the right will hold those numbers.</a:t>
             </a:r>
             <a:endParaRPr lang="en-US" dirty="0"/>
           </a:p>
@@ -4284,7 +4311,7 @@
                   <a:schemeClr val="tx1"/>
                 </a:solidFill>
               </a:rPr>
-              <a:t>≈ 6 s per epoch</a:t>
+              <a:t>&lt; 10 s per epoch</a:t>
             </a:r>
             <a:endParaRPr lang="en-US" sz="1400" dirty="0"/>
           </a:p>
@@ -7305,21 +7332,57 @@
                   <a:schemeClr val="tx1"/>
                 </a:solidFill>
               </a:rPr>
-              <a:t>With size: length errors −39 %, others unchanged</a:t>
+              <a:t>Size helps – but runs vary more than we thought</a:t>
             </a:r>
             <a:endParaRPr lang="en-US" sz="2600" dirty="0"/>
           </a:p>
         </p:txBody>
       </p:sp>
+      <p:sp>
+        <p:nvSpPr>
+          <p:cNvPr id="3" name="Text 1"/>
+          <p:cNvSpPr txBox="1"/>
+          <p:nvPr/>
+        </p:nvSpPr>
+        <p:spPr>
+          <a:xfrm>
+            <a:off x="457200" y="1051560"/>
+            <a:ext cx="4937760" cy="274320"/>
+          </a:xfrm>
+          <a:prstGeom prst="rect">
+            <a:avLst/>
+          </a:prstGeom>
+          <a:noFill/>
+          <a:ln/>
+        </p:spPr>
+        <p:txBody>
+          <a:bodyPr wrap="square" lIns="0" tIns="0" rIns="0" bIns="0" rtlCol="0" anchor="t"/>
+          <a:lstStyle/>
+          <a:p>
+            <a:pPr indent="0" marL="0">
+              <a:buNone/>
+            </a:pPr>
+            <a:r>
+              <a:rPr lang="en-US" sz="1200" dirty="0">
+                <a:solidFill>
+                  <a:schemeClr val="accent4"/>
+                </a:solidFill>
+              </a:rPr>
+              <a:t>Length / size errors on the render test set (4,000 images)</a:t>
+            </a:r>
+            <a:endParaRPr lang="en-US" sz="1200" dirty="0"/>
+          </a:p>
+        </p:txBody>
+      </p:sp>
       <p:graphicFrame>
         <p:nvGraphicFramePr>
-          <p:cNvPr id="3" name="Errors by type chart" descr=""/>
+          <p:cNvPr id="4" name="Length errors per run chart" descr=""/>
           <p:cNvGraphicFramePr/>
           <p:nvPr/>
         </p:nvGraphicFramePr>
         <p:xfrm>
-          <a:off x="457200" y="1097280"/>
-          <a:ext cx="4937760" cy="3429000"/>
+          <a:off x="457200" y="1325880"/>
+          <a:ext cx="4937760" cy="3246120"/>
         </p:xfrm>
         <a:graphic xmlns:a="http://schemas.openxmlformats.org/drawingml/2006/main">
           <a:graphicData uri="http://schemas.openxmlformats.org/drawingml/2006/chart">
@@ -7329,13 +7392,13 @@
       </p:graphicFrame>
       <p:sp>
         <p:nvSpPr>
-          <p:cNvPr id="4" name="Text 1"/>
+          <p:cNvPr id="5" name="Text 2"/>
           <p:cNvSpPr txBox="1"/>
           <p:nvPr/>
         </p:nvSpPr>
         <p:spPr>
           <a:xfrm>
-            <a:off x="5760720" y="1143000"/>
+            <a:off x="5760720" y="1097280"/>
             <a:ext cx="2926080" cy="502920"/>
           </a:xfrm>
           <a:prstGeom prst="rect">
@@ -7352,7 +7415,7 @@
               <a:buNone/>
             </a:pPr>
             <a:r>
-              <a:rPr lang="en-US" sz="3000" b="1" dirty="0">
+              <a:rPr lang="en-US" sz="2600" b="1" dirty="0">
                 <a:solidFill>
                   <a:schemeClr val="accent1"/>
                 </a:solidFill>
@@ -7360,21 +7423,21 @@
                 <a:ea typeface="Arial" pitchFamily="34" charset="-122"/>
                 <a:cs typeface="Arial" pitchFamily="34" charset="-120"/>
               </a:rPr>
-              <a:t>−39 %</a:t>
+              <a:t>70 vs 81–115</a:t>
             </a:r>
-            <a:endParaRPr lang="en-US" sz="3000" dirty="0"/>
-          </a:p>
-        </p:txBody>
-      </p:sp>
-      <p:sp>
-        <p:nvSpPr>
-          <p:cNvPr id="5" name="Text 2"/>
+            <a:endParaRPr lang="en-US" sz="2600" dirty="0"/>
+          </a:p>
+        </p:txBody>
+      </p:sp>
+      <p:sp>
+        <p:nvSpPr>
+          <p:cNvPr id="6" name="Text 3"/>
           <p:cNvSpPr txBox="1"/>
           <p:nvPr/>
         </p:nvSpPr>
         <p:spPr>
           <a:xfrm>
-            <a:off x="5760720" y="1645920"/>
+            <a:off x="5760720" y="1600200"/>
             <a:ext cx="2926080" cy="274320"/>
           </a:xfrm>
           <a:prstGeom prst="rect">
@@ -7396,7 +7459,7 @@
                   <a:schemeClr val="tx1"/>
                 </a:solidFill>
               </a:rPr>
-              <a:t>length / size errors (115 → 70)</a:t>
+              <a:t>length errors: with size vs. three baseline runs</a:t>
             </a:r>
             <a:endParaRPr lang="en-US" sz="1200" dirty="0"/>
           </a:p>
@@ -7404,13 +7467,13 @@
       </p:sp>
       <p:sp>
         <p:nvSpPr>
-          <p:cNvPr id="6" name="Text 3"/>
+          <p:cNvPr id="7" name="Text 4"/>
           <p:cNvSpPr txBox="1"/>
           <p:nvPr/>
         </p:nvSpPr>
         <p:spPr>
           <a:xfrm>
-            <a:off x="5760720" y="2011680"/>
+            <a:off x="5760720" y="1965960"/>
             <a:ext cx="2926080" cy="502920"/>
           </a:xfrm>
           <a:prstGeom prst="rect">
@@ -7427,7 +7490,7 @@
               <a:buNone/>
             </a:pPr>
             <a:r>
-              <a:rPr lang="en-US" sz="3000" b="1" dirty="0">
+              <a:rPr lang="en-US" sz="2600" b="1" dirty="0">
                 <a:solidFill>
                   <a:schemeClr val="accent4"/>
                 </a:solidFill>
@@ -7435,21 +7498,21 @@
                 <a:ea typeface="Arial" pitchFamily="34" charset="-122"/>
                 <a:cs typeface="Arial" pitchFamily="34" charset="-120"/>
               </a:rPr>
-              <a:t>± 0</a:t>
+              <a:t>up to 34</a:t>
             </a:r>
-            <a:endParaRPr lang="en-US" sz="3000" dirty="0"/>
-          </a:p>
-        </p:txBody>
-      </p:sp>
-      <p:sp>
-        <p:nvSpPr>
-          <p:cNvPr id="7" name="Text 4"/>
+            <a:endParaRPr lang="en-US" sz="2600" dirty="0"/>
+          </a:p>
+        </p:txBody>
+      </p:sp>
+      <p:sp>
+        <p:nvSpPr>
+          <p:cNvPr id="8" name="Text 5"/>
           <p:cNvSpPr txBox="1"/>
           <p:nvPr/>
         </p:nvSpPr>
         <p:spPr>
           <a:xfrm>
-            <a:off x="5760720" y="2514600"/>
+            <a:off x="5760720" y="2468880"/>
             <a:ext cx="2926080" cy="274320"/>
           </a:xfrm>
           <a:prstGeom prst="rect">
@@ -7471,7 +7534,7 @@
                   <a:schemeClr val="tx1"/>
                 </a:solidFill>
               </a:rPr>
-              <a:t>all other errors (137 → 138)</a:t>
+              <a:t>errors between runs of the SAME config</a:t>
             </a:r>
             <a:endParaRPr lang="en-US" sz="1200" dirty="0"/>
           </a:p>
@@ -7479,14 +7542,14 @@
       </p:sp>
       <p:sp>
         <p:nvSpPr>
-          <p:cNvPr id="8" name="Text 5"/>
+          <p:cNvPr id="9" name="Text 6"/>
           <p:cNvSpPr txBox="1"/>
           <p:nvPr/>
         </p:nvSpPr>
         <p:spPr>
           <a:xfrm>
-            <a:off x="5760720" y="2880360"/>
-            <a:ext cx="2926080" cy="502920"/>
+            <a:off x="5760720" y="2926080"/>
+            <a:ext cx="2926080" cy="274320"/>
           </a:xfrm>
           <a:prstGeom prst="rect">
             <a:avLst/>
@@ -7495,37 +7558,404 @@
           <a:ln/>
         </p:spPr>
         <p:txBody>
-          <a:bodyPr wrap="square" lIns="0" tIns="0" rIns="0" bIns="0" rtlCol="0" anchor="b"/>
+          <a:bodyPr wrap="square" lIns="0" tIns="0" rIns="0" bIns="0" rtlCol="0" anchor="t"/>
           <a:lstStyle/>
           <a:p>
             <a:pPr indent="0" marL="0">
               <a:buNone/>
             </a:pPr>
             <a:r>
-              <a:rPr lang="en-US" sz="3000" b="1" dirty="0">
+              <a:rPr lang="en-US" sz="1200" b="1" dirty="0">
                 <a:solidFill>
-                  <a:schemeClr val="accent1"/>
+                  <a:schemeClr val="tx1"/>
                 </a:solidFill>
-                <a:latin typeface="Arial" pitchFamily="34" charset="0"/>
-                <a:ea typeface="Arial" pitchFamily="34" charset="-122"/>
-                <a:cs typeface="Arial" pitchFamily="34" charset="-120"/>
               </a:rPr>
-              <a:t>94.8 %</a:t>
+              <a:t>Seeds 0–3 per config (pending)</a:t>
             </a:r>
-            <a:endParaRPr lang="en-US" sz="3000" dirty="0"/>
-          </a:p>
-        </p:txBody>
-      </p:sp>
-      <p:sp>
-        <p:nvSpPr>
-          <p:cNvPr id="9" name="Text 6"/>
+            <a:endParaRPr lang="en-US" sz="1200" dirty="0"/>
+          </a:p>
+        </p:txBody>
+      </p:sp>
+      <p:graphicFrame>
+        <p:nvGraphicFramePr>
+          <p:cNvPr id="7" name="Seed results table"/>
+          <p:cNvGraphicFramePr>
+            <a:graphicFrameLocks noGrp="1"/>
+          </p:cNvGraphicFramePr>
+          <p:nvPr>
+            <p:extLst>
+              <p:ext uri="{D42A27DB-BD31-4B8C-83A1-F6EECF244321}">
+                <p14:modId xmlns:p14="http://schemas.microsoft.com/office/powerpoint/2010/main" val="1579011935"/>
+              </p:ext>
+            </p:extLst>
+          </p:nvPr>
+        </p:nvGraphicFramePr>
+        <p:xfrm>
+          <a:off x="5760720" y="3246120"/>
+          <a:ext cx="2926080" cy="914400"/>
+        </p:xfrm>
+        <a:graphic>
+          <a:graphicData uri="http://schemas.openxmlformats.org/drawingml/2006/table">
+            <a:tbl>
+              <a:tblPr/>
+              <a:tblGrid>
+                <a:gridCol w="1188720"/>
+                <a:gridCol w="731520"/>
+                <a:gridCol w="1005840"/>
+              </a:tblGrid>
+              <a:tr h="292608">
+                <a:tc>
+                  <a:txBody>
+                    <a:bodyPr/>
+                    <a:lstStyle/>
+                    <a:p>
+                      <a:pPr indent="0" marL="0">
+                        <a:buNone/>
+                      </a:pPr>
+                      <a:r>
+                        <a:rPr lang="en-US" sz="1100" b="1" dirty="0">
+                          <a:solidFill>
+                            <a:schemeClr val="bg1"/>
+                          </a:solidFill>
+                        </a:rPr>
+                        <a:t>Config</a:t>
+                      </a:r>
+                      <a:endParaRPr lang="en-US" sz="1100" dirty="0"/>
+                    </a:p>
+                  </a:txBody>
+                  <a:tcPr marL="73152" marR="73152" marT="0" marB="0" anchor="ctr">
+                    <a:lnL w="0" cap="flat" cmpd="sng" algn="ctr">
+                      <a:noFill/>
+                    </a:lnL>
+                    <a:lnR w="0" cap="flat" cmpd="sng" algn="ctr">
+                      <a:noFill/>
+                    </a:lnR>
+                    <a:lnT w="0" cap="flat" cmpd="sng" algn="ctr">
+                      <a:noFill/>
+                    </a:lnT>
+                    <a:lnB w="0" cap="flat" cmpd="sng" algn="ctr">
+                      <a:noFill/>
+                    </a:lnB>
+                    <a:solidFill>
+                      <a:schemeClr val="tx2"/>
+                    </a:solidFill>
+                  </a:tcPr>
+                </a:tc>
+                <a:tc>
+                  <a:txBody>
+                    <a:bodyPr/>
+                    <a:lstStyle/>
+                    <a:p>
+                      <a:pPr algn="r" indent="0" marL="0">
+                        <a:buNone/>
+                      </a:pPr>
+                      <a:r>
+                        <a:rPr lang="en-US" sz="1100" b="1" dirty="0">
+                          <a:solidFill>
+                            <a:schemeClr val="bg1"/>
+                          </a:solidFill>
+                        </a:rPr>
+                        <a:t>Top-1</a:t>
+                      </a:r>
+                      <a:endParaRPr lang="en-US" sz="1100" dirty="0"/>
+                    </a:p>
+                  </a:txBody>
+                  <a:tcPr marL="73152" marR="73152" marT="0" marB="0" anchor="ctr">
+                    <a:lnL w="0" cap="flat" cmpd="sng" algn="ctr">
+                      <a:noFill/>
+                    </a:lnL>
+                    <a:lnR w="0" cap="flat" cmpd="sng" algn="ctr">
+                      <a:noFill/>
+                    </a:lnR>
+                    <a:lnT w="0" cap="flat" cmpd="sng" algn="ctr">
+                      <a:noFill/>
+                    </a:lnT>
+                    <a:lnB w="0" cap="flat" cmpd="sng" algn="ctr">
+                      <a:noFill/>
+                    </a:lnB>
+                    <a:solidFill>
+                      <a:schemeClr val="tx2"/>
+                    </a:solidFill>
+                  </a:tcPr>
+                </a:tc>
+                <a:tc>
+                  <a:txBody>
+                    <a:bodyPr/>
+                    <a:lstStyle/>
+                    <a:p>
+                      <a:pPr algn="r" indent="0" marL="0">
+                        <a:buNone/>
+                      </a:pPr>
+                      <a:r>
+                        <a:rPr lang="en-US" sz="1100" b="1" dirty="0">
+                          <a:solidFill>
+                            <a:schemeClr val="bg1"/>
+                          </a:solidFill>
+                        </a:rPr>
+                        <a:t>Length err.</a:t>
+                      </a:r>
+                      <a:endParaRPr lang="en-US" sz="1100" dirty="0"/>
+                    </a:p>
+                  </a:txBody>
+                  <a:tcPr marL="73152" marR="73152" marT="0" marB="0" anchor="ctr">
+                    <a:lnL w="0" cap="flat" cmpd="sng" algn="ctr">
+                      <a:noFill/>
+                    </a:lnL>
+                    <a:lnR w="0" cap="flat" cmpd="sng" algn="ctr">
+                      <a:noFill/>
+                    </a:lnR>
+                    <a:lnT w="0" cap="flat" cmpd="sng" algn="ctr">
+                      <a:noFill/>
+                    </a:lnT>
+                    <a:lnB w="0" cap="flat" cmpd="sng" algn="ctr">
+                      <a:noFill/>
+                    </a:lnB>
+                    <a:solidFill>
+                      <a:schemeClr val="tx2"/>
+                    </a:solidFill>
+                  </a:tcPr>
+                </a:tc>
+              </a:tr>
+              <a:tr h="292608">
+                <a:tc>
+                  <a:txBody>
+                    <a:bodyPr/>
+                    <a:lstStyle/>
+                    <a:p>
+                      <a:pPr indent="0" marL="0">
+                        <a:buNone/>
+                      </a:pPr>
+                      <a:r>
+                        <a:rPr lang="en-US" sz="1100" dirty="0">
+                          <a:solidFill>
+                            <a:schemeClr val="tx1"/>
+                          </a:solidFill>
+                        </a:rPr>
+                        <a:t>Baseline</a:t>
+                      </a:r>
+                      <a:endParaRPr lang="en-US" sz="1100" dirty="0"/>
+                    </a:p>
+                  </a:txBody>
+                  <a:tcPr marL="73152" marR="73152" marT="0" marB="0" anchor="ctr">
+                    <a:lnL w="0" cap="flat" cmpd="sng" algn="ctr">
+                      <a:noFill/>
+                    </a:lnL>
+                    <a:lnR w="0" cap="flat" cmpd="sng" algn="ctr">
+                      <a:noFill/>
+                    </a:lnR>
+                    <a:lnT w="0" cap="flat" cmpd="sng" algn="ctr">
+                      <a:noFill/>
+                    </a:lnT>
+                    <a:lnB w="0" cap="flat" cmpd="sng" algn="ctr">
+                      <a:noFill/>
+                    </a:lnB>
+                    <a:solidFill>
+                      <a:schemeClr val="bg2"/>
+                    </a:solidFill>
+                  </a:tcPr>
+                </a:tc>
+                <a:tc>
+                  <a:txBody>
+                    <a:bodyPr/>
+                    <a:lstStyle/>
+                    <a:p>
+                      <a:pPr algn="r" indent="0" marL="0">
+                        <a:buNone/>
+                      </a:pPr>
+                      <a:r>
+                        <a:rPr lang="en-US" sz="1100" dirty="0">
+                          <a:solidFill>
+                            <a:schemeClr val="tx1"/>
+                          </a:solidFill>
+                        </a:rPr>
+                        <a:t>tbd</a:t>
+                      </a:r>
+                      <a:endParaRPr lang="en-US" sz="1100" dirty="0"/>
+                    </a:p>
+                  </a:txBody>
+                  <a:tcPr marL="73152" marR="73152" marT="0" marB="0" anchor="ctr">
+                    <a:lnL w="0" cap="flat" cmpd="sng" algn="ctr">
+                      <a:noFill/>
+                    </a:lnL>
+                    <a:lnR w="0" cap="flat" cmpd="sng" algn="ctr">
+                      <a:noFill/>
+                    </a:lnR>
+                    <a:lnT w="0" cap="flat" cmpd="sng" algn="ctr">
+                      <a:noFill/>
+                    </a:lnT>
+                    <a:lnB w="0" cap="flat" cmpd="sng" algn="ctr">
+                      <a:noFill/>
+                    </a:lnB>
+                    <a:solidFill>
+                      <a:schemeClr val="bg2"/>
+                    </a:solidFill>
+                  </a:tcPr>
+                </a:tc>
+                <a:tc>
+                  <a:txBody>
+                    <a:bodyPr/>
+                    <a:lstStyle/>
+                    <a:p>
+                      <a:pPr algn="r" indent="0" marL="0">
+                        <a:buNone/>
+                      </a:pPr>
+                      <a:r>
+                        <a:rPr lang="en-US" sz="1100" dirty="0">
+                          <a:solidFill>
+                            <a:schemeClr val="tx1"/>
+                          </a:solidFill>
+                        </a:rPr>
+                        <a:t>tbd</a:t>
+                      </a:r>
+                      <a:endParaRPr lang="en-US" sz="1100" dirty="0"/>
+                    </a:p>
+                  </a:txBody>
+                  <a:tcPr marL="73152" marR="73152" marT="0" marB="0" anchor="ctr">
+                    <a:lnL w="0" cap="flat" cmpd="sng" algn="ctr">
+                      <a:noFill/>
+                    </a:lnL>
+                    <a:lnR w="0" cap="flat" cmpd="sng" algn="ctr">
+                      <a:noFill/>
+                    </a:lnR>
+                    <a:lnT w="0" cap="flat" cmpd="sng" algn="ctr">
+                      <a:noFill/>
+                    </a:lnT>
+                    <a:lnB w="0" cap="flat" cmpd="sng" algn="ctr">
+                      <a:noFill/>
+                    </a:lnB>
+                    <a:solidFill>
+                      <a:schemeClr val="bg2"/>
+                    </a:solidFill>
+                  </a:tcPr>
+                </a:tc>
+              </a:tr>
+              <a:tr h="292608">
+                <a:tc>
+                  <a:txBody>
+                    <a:bodyPr/>
+                    <a:lstStyle/>
+                    <a:p>
+                      <a:pPr indent="0" marL="0">
+                        <a:buNone/>
+                      </a:pPr>
+                      <a:r>
+                        <a:rPr lang="en-US" sz="1100" dirty="0">
+                          <a:solidFill>
+                            <a:schemeClr val="tx1"/>
+                          </a:solidFill>
+                        </a:rPr>
+                        <a:t>With size</a:t>
+                      </a:r>
+                      <a:endParaRPr lang="en-US" sz="1100" dirty="0"/>
+                    </a:p>
+                  </a:txBody>
+                  <a:tcPr marL="73152" marR="73152" marT="0" marB="0" anchor="ctr">
+                    <a:lnL w="0" cap="flat" cmpd="sng" algn="ctr">
+                      <a:noFill/>
+                    </a:lnL>
+                    <a:lnR w="0" cap="flat" cmpd="sng" algn="ctr">
+                      <a:noFill/>
+                    </a:lnR>
+                    <a:lnT w="0" cap="flat" cmpd="sng" algn="ctr">
+                      <a:noFill/>
+                    </a:lnT>
+                    <a:lnB w="0" cap="flat" cmpd="sng" algn="ctr">
+                      <a:noFill/>
+                    </a:lnB>
+                    <a:solidFill>
+                      <a:schemeClr val="bg2"/>
+                    </a:solidFill>
+                  </a:tcPr>
+                </a:tc>
+                <a:tc>
+                  <a:txBody>
+                    <a:bodyPr/>
+                    <a:lstStyle/>
+                    <a:p>
+                      <a:pPr algn="r" indent="0" marL="0">
+                        <a:buNone/>
+                      </a:pPr>
+                      <a:r>
+                        <a:rPr lang="en-US" sz="1100" dirty="0">
+                          <a:solidFill>
+                            <a:schemeClr val="tx1"/>
+                          </a:solidFill>
+                        </a:rPr>
+                        <a:t>tbd</a:t>
+                      </a:r>
+                      <a:endParaRPr lang="en-US" sz="1100" dirty="0"/>
+                    </a:p>
+                  </a:txBody>
+                  <a:tcPr marL="73152" marR="73152" marT="0" marB="0" anchor="ctr">
+                    <a:lnL w="0" cap="flat" cmpd="sng" algn="ctr">
+                      <a:noFill/>
+                    </a:lnL>
+                    <a:lnR w="0" cap="flat" cmpd="sng" algn="ctr">
+                      <a:noFill/>
+                    </a:lnR>
+                    <a:lnT w="0" cap="flat" cmpd="sng" algn="ctr">
+                      <a:noFill/>
+                    </a:lnT>
+                    <a:lnB w="0" cap="flat" cmpd="sng" algn="ctr">
+                      <a:noFill/>
+                    </a:lnB>
+                    <a:solidFill>
+                      <a:schemeClr val="bg2"/>
+                    </a:solidFill>
+                  </a:tcPr>
+                </a:tc>
+                <a:tc>
+                  <a:txBody>
+                    <a:bodyPr/>
+                    <a:lstStyle/>
+                    <a:p>
+                      <a:pPr algn="r" indent="0" marL="0">
+                        <a:buNone/>
+                      </a:pPr>
+                      <a:r>
+                        <a:rPr lang="en-US" sz="1100" dirty="0">
+                          <a:solidFill>
+                            <a:schemeClr val="tx1"/>
+                          </a:solidFill>
+                        </a:rPr>
+                        <a:t>tbd</a:t>
+                      </a:r>
+                      <a:endParaRPr lang="en-US" sz="1100" dirty="0"/>
+                    </a:p>
+                  </a:txBody>
+                  <a:tcPr marL="73152" marR="73152" marT="0" marB="0" anchor="ctr">
+                    <a:lnL w="0" cap="flat" cmpd="sng" algn="ctr">
+                      <a:noFill/>
+                    </a:lnL>
+                    <a:lnR w="0" cap="flat" cmpd="sng" algn="ctr">
+                      <a:noFill/>
+                    </a:lnR>
+                    <a:lnT w="0" cap="flat" cmpd="sng" algn="ctr">
+                      <a:noFill/>
+                    </a:lnT>
+                    <a:lnB w="0" cap="flat" cmpd="sng" algn="ctr">
+                      <a:noFill/>
+                    </a:lnB>
+                    <a:solidFill>
+                      <a:schemeClr val="bg2"/>
+                    </a:solidFill>
+                  </a:tcPr>
+                </a:tc>
+              </a:tr>
+            </a:tbl>
+          </a:graphicData>
+        </a:graphic>
+      </p:graphicFrame>
+      <p:sp>
+        <p:nvSpPr>
+          <p:cNvPr id="11" name="Text 7"/>
           <p:cNvSpPr txBox="1"/>
           <p:nvPr/>
         </p:nvSpPr>
         <p:spPr>
           <a:xfrm>
-            <a:off x="5760720" y="3383280"/>
-            <a:ext cx="2926080" cy="274320"/>
+            <a:off x="5760720" y="4206240"/>
+            <a:ext cx="2926080" cy="320040"/>
           </a:xfrm>
           <a:prstGeom prst="rect">
             <a:avLst/>
@@ -7541,79 +7971,14 @@
               <a:buNone/>
             </a:pPr>
             <a:r>
-              <a:rPr lang="en-US" sz="1200" dirty="0">
+              <a:rPr lang="en-US" sz="1000" i="1" dirty="0">
                 <a:solidFill>
-                  <a:schemeClr val="tx1"/>
+                  <a:schemeClr val="accent4"/>
                 </a:solidFill>
               </a:rPr>
-              <a:t>top-1 overall (was 93.7 %)</a:t>
+              <a:t>Mean ± range, to be filled in after the seed runs.</a:t>
             </a:r>
-            <a:endParaRPr lang="en-US" sz="1200" dirty="0"/>
-          </a:p>
-        </p:txBody>
-      </p:sp>
-      <p:sp>
-        <p:nvSpPr>
-          <p:cNvPr id="10" name="Seed caveat card"/>
-          <p:cNvSpPr/>
-          <p:nvPr/>
-        </p:nvSpPr>
-        <p:spPr>
-          <a:xfrm>
-            <a:off x="5760720" y="3840480"/>
-            <a:ext cx="2926080" cy="685800"/>
-          </a:xfrm>
-          <a:prstGeom prst="roundRect">
-            <a:avLst>
-              <a:gd name="adj" fmla="val 10667"/>
-            </a:avLst>
-          </a:prstGeom>
-          <a:solidFill>
-            <a:schemeClr val="bg2"/>
-          </a:solidFill>
-          <a:ln w="12700">
-            <a:solidFill>
-              <a:schemeClr val="bg2">
-                <a:alpha val="0"/>
-              </a:schemeClr>
-            </a:solidFill>
-            <a:prstDash val="solid"/>
-          </a:ln>
-        </p:spPr>
-      </p:sp>
-      <p:sp>
-        <p:nvSpPr>
-          <p:cNvPr id="11" name="Text 8"/>
-          <p:cNvSpPr txBox="1"/>
-          <p:nvPr/>
-        </p:nvSpPr>
-        <p:spPr>
-          <a:xfrm>
-            <a:off x="5897880" y="3886200"/>
-            <a:ext cx="2697480" cy="594360"/>
-          </a:xfrm>
-          <a:prstGeom prst="rect">
-            <a:avLst/>
-          </a:prstGeom>
-          <a:noFill/>
-          <a:ln/>
-        </p:spPr>
-        <p:txBody>
-          <a:bodyPr wrap="square" lIns="0" tIns="0" rIns="0" bIns="0" rtlCol="0" anchor="ctr"/>
-          <a:lstStyle/>
-          <a:p>
-            <a:pPr indent="0" marL="0">
-              <a:buNone/>
-            </a:pPr>
-            <a:r>
-              <a:rPr lang="en-US" sz="1100" i="1" dirty="0">
-                <a:solidFill>
-                  <a:schemeClr val="tx1"/>
-                </a:solidFill>
-              </a:rPr>
-              <a:t>One run per variant so far – more seeds before we call it final.</a:t>
-            </a:r>
-            <a:endParaRPr lang="en-US" sz="1100" dirty="0"/>
+            <a:endParaRPr lang="en-US" sz="1000" dirty="0"/>
           </a:p>
         </p:txBody>
       </p:sp>
@@ -8463,7 +8828,7 @@
                   <a:schemeClr val="bg1"/>
                 </a:solidFill>
               </a:rPr>
-              <a:t>Three seeds per variant before we report the size effect as final.</a:t>
+              <a:t>Runs of the same config differ by up to 34 errors: always several seeds.</a:t>
             </a:r>
             <a:endParaRPr lang="en-US" sz="1300" dirty="0"/>
           </a:p>

</xml_diff>

<commit_message>
docs: robust mask, contrast stretch, correction of the size-feature effect (#16)
- experiments.md: new entry 2026-10-29 with all render runs so far, the
  contrast experiment and a placeholder table for the seed runs
- correction: baseline runs of the same config differ by up to 34 length
  errors, so the -39 % for the size feature compared against the worst run
- slides: slide 6 shows all baseline runs vs the size feature, seed table to
  be filled in; small fixes on slides 2 and 7


Claude-Session: https://claude.ai/code/session_016ynpjMZGN2P6wMb6kjy8nN

Co-authored-by: Claude Opus 5.5 <noreply@anthropic.com>
</commit_message>
<xml_diff>
--- a/docs/presentations/2026-10-23_progress_shape_v0.pptx
+++ b/docs/presentations/2026-10-23_progress_shape_v0.pptx
@@ -113,25 +113,25 @@
   <p:extLst>
     <p:ext uri="{521415D9-36F7-43E2-AB2F-B90AF26B5E84}">
       <p14:sectionLst xmlns:p14="http://schemas.microsoft.com/office/powerpoint/2010/main">
-        <p14:section name="Intro" id="{b2890869-46ad-bb02-70fd-2c190978498a}">
+        <p14:section name="Intro" id="{f6bce8f0-2bb2-61ed-ff4a-43c9b0d81e0c}">
           <p14:sldIdLst>
             <p14:sldId id="256"/>
           </p14:sldIdLst>
         </p14:section>
-        <p14:section name="Setup and baseline" id="{3df84820-bd91-9379-5a10-1afd019b1efe}">
+        <p14:section name="Setup and baseline" id="{6f33a436-d3e5-1b1c-2bd9-ca5f7c71af3f}">
           <p14:sldIdLst>
             <p14:sldId id="257"/>
             <p14:sldId id="258"/>
           </p14:sldIdLst>
         </p14:section>
-        <p14:section name="Error analysis" id="{a138ea59-9b1e-45c2-ec32-480401f014c2}">
+        <p14:section name="Error analysis" id="{3374d702-c2e2-0bca-432a-c663ae25fc18}">
           <p14:sldIdLst>
             <p14:sldId id="259"/>
             <p14:sldId id="260"/>
             <p14:sldId id="261"/>
           </p14:sldIdLst>
         </p14:section>
-        <p14:section name="Next steps" id="{792c7912-3e7d-ba4d-19d8-5375b385b47b}">
+        <p14:section name="Next steps" id="{17c028b5-114b-3492-1be0-9fe58fd0a513}">
           <p14:sldIdLst>
             <p14:sldId id="262"/>
           </p14:sldIdLst>
@@ -524,7 +524,7 @@
       <c:layout/>
       <c:barChart>
         <c:barDir val="col"/>
-        <c:grouping val="clustered"/>
+        <c:grouping val="stacked"/>
         <c:varyColors val="0"/>
         <c:ser>
           <c:idx val="0"/>
@@ -535,7 +535,7 @@
               <c:strCache>
                 <c:ptCount val="1"/>
                 <c:pt idx="0">
-                  <c:v>Without size</c:v>
+                  <c:v>Baseline (same config, 3 runs)</c:v>
                 </c:pt>
               </c:strCache>
             </c:strRef>
@@ -548,7 +548,7 @@
           </c:spPr>
           <c:invertIfNegative val="0"/>
           <c:dLbls>
-            <c:numFmt formatCode="#,##0" sourceLinked="0"/>
+            <c:numFmt formatCode="0;;;" sourceLinked="0"/>
             <c:txPr>
               <a:bodyPr/>
               <a:lstStyle/>
@@ -556,13 +556,14 @@
                 <a:pPr>
                   <a:defRPr b="1" i="0" strike="noStrike" sz="1200" u="none">
                     <a:solidFill>
-                      <a:srgbClr val="1E2530"/>
+                      <a:srgbClr val="FFFFFF"/>
                     </a:solidFill>
                     <a:latin typeface="+mn-lt"/>
                   </a:defRPr>
                 </a:pPr>
               </a:p>
             </c:txPr>
+            <c:dLblPos val="inEnd"/>
             <c:showLegendKey val="0"/>
             <c:showVal val="1"/>
             <c:showCatName val="0"/>
@@ -573,15 +574,21 @@
           </c:dLbls>
           <c:cat>
             <c:multiLvlStrRef>
-              <c:f>Sheet1!$A$2:$A$3</c:f>
+              <c:f>Sheet1!$A$2:$A$5</c:f>
               <c:multiLvlStrCache>
-                <c:ptCount val="2"/>
+                <c:ptCount val="4"/>
                 <c:lvl>
                   <c:pt idx="0">
-                    <c:v>Length / size errors</c:v>
+                    <c:v>Baseline run A</c:v>
                   </c:pt>
                   <c:pt idx="1">
-                    <c:v>All other errors</c:v>
+                    <c:v>Baseline run B</c:v>
+                  </c:pt>
+                  <c:pt idx="2">
+                    <c:v>Baseline run C</c:v>
+                  </c:pt>
+                  <c:pt idx="3">
+                    <c:v>With size</c:v>
                   </c:pt>
                 </c:lvl>
               </c:multiLvlStrCache>
@@ -589,15 +596,21 @@
           </c:cat>
           <c:val>
             <c:numRef>
-              <c:f>Sheet1!$B$2:$B$3</c:f>
+              <c:f>Sheet1!$B$2:$B$5</c:f>
               <c:numCache>
                 <c:formatCode>General</c:formatCode>
-                <c:ptCount val="2"/>
+                <c:ptCount val="4"/>
                 <c:pt idx="0">
                   <c:v>115</c:v>
                 </c:pt>
                 <c:pt idx="1">
-                  <c:v>137</c:v>
+                  <c:v>81</c:v>
+                </c:pt>
+                <c:pt idx="2">
+                  <c:v>83</c:v>
+                </c:pt>
+                <c:pt idx="3">
+                  <c:v>0</c:v>
                 </c:pt>
               </c:numCache>
             </c:numRef>
@@ -612,7 +625,7 @@
               <c:strCache>
                 <c:ptCount val="1"/>
                 <c:pt idx="0">
-                  <c:v>With size</c:v>
+                  <c:v>With size (1 run)</c:v>
                 </c:pt>
               </c:strCache>
             </c:strRef>
@@ -625,7 +638,7 @@
           </c:spPr>
           <c:invertIfNegative val="0"/>
           <c:dLbls>
-            <c:numFmt formatCode="#,##0" sourceLinked="0"/>
+            <c:numFmt formatCode="0;;;" sourceLinked="0"/>
             <c:txPr>
               <a:bodyPr/>
               <a:lstStyle/>
@@ -633,13 +646,14 @@
                 <a:pPr>
                   <a:defRPr b="1" i="0" strike="noStrike" sz="1200" u="none">
                     <a:solidFill>
-                      <a:srgbClr val="1E2530"/>
+                      <a:srgbClr val="FFFFFF"/>
                     </a:solidFill>
                     <a:latin typeface="+mn-lt"/>
                   </a:defRPr>
                 </a:pPr>
               </a:p>
             </c:txPr>
+            <c:dLblPos val="inEnd"/>
             <c:showLegendKey val="0"/>
             <c:showVal val="1"/>
             <c:showCatName val="0"/>
@@ -650,15 +664,21 @@
           </c:dLbls>
           <c:cat>
             <c:multiLvlStrRef>
-              <c:f>Sheet1!$A$2:$A$3</c:f>
+              <c:f>Sheet1!$A$2:$A$5</c:f>
               <c:multiLvlStrCache>
-                <c:ptCount val="2"/>
+                <c:ptCount val="4"/>
                 <c:lvl>
                   <c:pt idx="0">
-                    <c:v>Length / size errors</c:v>
+                    <c:v>Baseline run A</c:v>
                   </c:pt>
                   <c:pt idx="1">
-                    <c:v>All other errors</c:v>
+                    <c:v>Baseline run B</c:v>
+                  </c:pt>
+                  <c:pt idx="2">
+                    <c:v>Baseline run C</c:v>
+                  </c:pt>
+                  <c:pt idx="3">
+                    <c:v>With size</c:v>
                   </c:pt>
                 </c:lvl>
               </c:multiLvlStrCache>
@@ -666,22 +686,28 @@
           </c:cat>
           <c:val>
             <c:numRef>
-              <c:f>Sheet1!$C$2:$C$3</c:f>
+              <c:f>Sheet1!$C$2:$C$5</c:f>
               <c:numCache>
                 <c:formatCode>General</c:formatCode>
-                <c:ptCount val="2"/>
+                <c:ptCount val="4"/>
                 <c:pt idx="0">
-                  <c:v>70</c:v>
+                  <c:v>0</c:v>
                 </c:pt>
                 <c:pt idx="1">
-                  <c:v>138</c:v>
+                  <c:v>0</c:v>
+                </c:pt>
+                <c:pt idx="2">
+                  <c:v>0</c:v>
+                </c:pt>
+                <c:pt idx="3">
+                  <c:v>70</c:v>
                 </c:pt>
               </c:numCache>
             </c:numRef>
           </c:val>
         </c:ser>
         <c:dLbls>
-          <c:numFmt formatCode="#,##0" sourceLinked="0"/>
+          <c:numFmt formatCode="0;;;" sourceLinked="0"/>
           <c:txPr>
             <a:bodyPr/>
             <a:lstStyle/>
@@ -689,13 +715,14 @@
               <a:pPr>
                 <a:defRPr b="1" i="0" strike="noStrike" sz="1200" u="none">
                   <a:solidFill>
-                    <a:srgbClr val="1E2530"/>
+                    <a:srgbClr val="FFFFFF"/>
                   </a:solidFill>
                   <a:latin typeface="+mn-lt"/>
                 </a:defRPr>
               </a:pPr>
             </a:p>
           </c:txPr>
+          <c:dLblPos val="inEnd"/>
           <c:showLegendKey val="0"/>
           <c:showVal val="1"/>
           <c:showCatName val="0"/>
@@ -704,8 +731,8 @@
           <c:showBubbleSize val="0"/>
           <c:showLeaderLines val="0"/>
         </c:dLbls>
-        <c:gapWidth val="70"/>
-        <c:overlap val="0"/>
+        <c:gapWidth val="55"/>
+        <c:overlap val="100"/>
         <c:axId val="2094734554"/>
         <c:axId val="2094734552"/>
         <c:axId val="2094734556"/>
@@ -735,7 +762,7 @@
           <a:lstStyle/>
           <a:p>
             <a:pPr>
-              <a:defRPr sz="1200" b="0" i="0" u="none" strike="noStrike">
+              <a:defRPr sz="1100" b="0" i="0" u="none" strike="noStrike">
                 <a:solidFill>
                   <a:srgbClr val="1E2530"/>
                 </a:solidFill>
@@ -755,7 +782,7 @@
         <c:axId val="2094734552"/>
         <c:scaling>
           <c:orientation val="minMax"/>
-          <c:max val="160"/>
+          <c:max val="125"/>
         </c:scaling>
         <c:delete val="1"/>
         <c:axPos val="l"/>
@@ -800,14 +827,14 @@
       </c:spPr>
     </c:plotArea>
     <c:legend>
-      <c:legendPos val="t"/>
+      <c:legendPos val="b"/>
       <c:overlay val="0"/>
       <c:txPr>
         <a:bodyPr/>
         <a:lstStyle/>
         <a:p>
           <a:pPr>
-            <a:defRPr sz="1100">
+            <a:defRPr sz="1000">
               <a:solidFill>
                 <a:srgbClr val="1E2530"/>
               </a:solidFill>
@@ -1670,7 +1697,7 @@
           <a:p>
             <a:r>
               <a:rPr lang="en-US" dirty="0"/>
-              <a:t>We kept the cropped image, so no details are lost, and gave the network the measured brick size as one extra number. During training we add about five percent noise to that number, because we will never measure size perfectly on real photos. The result: length errors drop from 115 to 70, minus 39 percent. All other errors stay exactly where they were, 137 versus 138. That second bar is our control: the change helps exactly where the hypothesis says it should, and nowhere else. Overall top-1 goes from 93.7 to 94.8 percent. This is one run per variant, so we will repeat it with more seeds.</a:t>
+              <a:t>We kept the cropped image and gave the network the measured brick size as one extra number, with about five percent noise during training. In our first comparison, length errors dropped from 115 to 70. But when we retrained the baseline with exactly the same settings, it made 81 and 83 length errors. So runs of the same configuration differ by up to 34 errors, and our first baseline was simply an unlucky run. Against the newer baselines the size feature still helps, but the effect is closer to 15 percent than to 40. That is why we now train every configuration with several seeds and report the mean and the range. The table on the right will hold those numbers.</a:t>
             </a:r>
             <a:endParaRPr lang="en-US" dirty="0"/>
           </a:p>
@@ -4284,7 +4311,7 @@
                   <a:schemeClr val="tx1"/>
                 </a:solidFill>
               </a:rPr>
-              <a:t>≈ 6 s per epoch</a:t>
+              <a:t>&lt; 10 s per epoch</a:t>
             </a:r>
             <a:endParaRPr lang="en-US" sz="1400" dirty="0"/>
           </a:p>
@@ -7305,21 +7332,57 @@
                   <a:schemeClr val="tx1"/>
                 </a:solidFill>
               </a:rPr>
-              <a:t>With size: length errors −39 %, others unchanged</a:t>
+              <a:t>Size helps – but runs vary more than we thought</a:t>
             </a:r>
             <a:endParaRPr lang="en-US" sz="2600" dirty="0"/>
           </a:p>
         </p:txBody>
       </p:sp>
+      <p:sp>
+        <p:nvSpPr>
+          <p:cNvPr id="3" name="Text 1"/>
+          <p:cNvSpPr txBox="1"/>
+          <p:nvPr/>
+        </p:nvSpPr>
+        <p:spPr>
+          <a:xfrm>
+            <a:off x="457200" y="1051560"/>
+            <a:ext cx="4937760" cy="274320"/>
+          </a:xfrm>
+          <a:prstGeom prst="rect">
+            <a:avLst/>
+          </a:prstGeom>
+          <a:noFill/>
+          <a:ln/>
+        </p:spPr>
+        <p:txBody>
+          <a:bodyPr wrap="square" lIns="0" tIns="0" rIns="0" bIns="0" rtlCol="0" anchor="t"/>
+          <a:lstStyle/>
+          <a:p>
+            <a:pPr indent="0" marL="0">
+              <a:buNone/>
+            </a:pPr>
+            <a:r>
+              <a:rPr lang="en-US" sz="1200" dirty="0">
+                <a:solidFill>
+                  <a:schemeClr val="accent4"/>
+                </a:solidFill>
+              </a:rPr>
+              <a:t>Length / size errors on the render test set (4,000 images)</a:t>
+            </a:r>
+            <a:endParaRPr lang="en-US" sz="1200" dirty="0"/>
+          </a:p>
+        </p:txBody>
+      </p:sp>
       <p:graphicFrame>
         <p:nvGraphicFramePr>
-          <p:cNvPr id="3" name="Errors by type chart" descr=""/>
+          <p:cNvPr id="4" name="Length errors per run chart" descr=""/>
           <p:cNvGraphicFramePr/>
           <p:nvPr/>
         </p:nvGraphicFramePr>
         <p:xfrm>
-          <a:off x="457200" y="1097280"/>
-          <a:ext cx="4937760" cy="3429000"/>
+          <a:off x="457200" y="1325880"/>
+          <a:ext cx="4937760" cy="3246120"/>
         </p:xfrm>
         <a:graphic xmlns:a="http://schemas.openxmlformats.org/drawingml/2006/main">
           <a:graphicData uri="http://schemas.openxmlformats.org/drawingml/2006/chart">
@@ -7329,13 +7392,13 @@
       </p:graphicFrame>
       <p:sp>
         <p:nvSpPr>
-          <p:cNvPr id="4" name="Text 1"/>
+          <p:cNvPr id="5" name="Text 2"/>
           <p:cNvSpPr txBox="1"/>
           <p:nvPr/>
         </p:nvSpPr>
         <p:spPr>
           <a:xfrm>
-            <a:off x="5760720" y="1143000"/>
+            <a:off x="5760720" y="1097280"/>
             <a:ext cx="2926080" cy="502920"/>
           </a:xfrm>
           <a:prstGeom prst="rect">
@@ -7352,7 +7415,7 @@
               <a:buNone/>
             </a:pPr>
             <a:r>
-              <a:rPr lang="en-US" sz="3000" b="1" dirty="0">
+              <a:rPr lang="en-US" sz="2600" b="1" dirty="0">
                 <a:solidFill>
                   <a:schemeClr val="accent1"/>
                 </a:solidFill>
@@ -7360,21 +7423,21 @@
                 <a:ea typeface="Arial" pitchFamily="34" charset="-122"/>
                 <a:cs typeface="Arial" pitchFamily="34" charset="-120"/>
               </a:rPr>
-              <a:t>−39 %</a:t>
+              <a:t>70 vs 81–115</a:t>
             </a:r>
-            <a:endParaRPr lang="en-US" sz="3000" dirty="0"/>
-          </a:p>
-        </p:txBody>
-      </p:sp>
-      <p:sp>
-        <p:nvSpPr>
-          <p:cNvPr id="5" name="Text 2"/>
+            <a:endParaRPr lang="en-US" sz="2600" dirty="0"/>
+          </a:p>
+        </p:txBody>
+      </p:sp>
+      <p:sp>
+        <p:nvSpPr>
+          <p:cNvPr id="6" name="Text 3"/>
           <p:cNvSpPr txBox="1"/>
           <p:nvPr/>
         </p:nvSpPr>
         <p:spPr>
           <a:xfrm>
-            <a:off x="5760720" y="1645920"/>
+            <a:off x="5760720" y="1600200"/>
             <a:ext cx="2926080" cy="274320"/>
           </a:xfrm>
           <a:prstGeom prst="rect">
@@ -7396,7 +7459,7 @@
                   <a:schemeClr val="tx1"/>
                 </a:solidFill>
               </a:rPr>
-              <a:t>length / size errors (115 → 70)</a:t>
+              <a:t>length errors: with size vs. three baseline runs</a:t>
             </a:r>
             <a:endParaRPr lang="en-US" sz="1200" dirty="0"/>
           </a:p>
@@ -7404,13 +7467,13 @@
       </p:sp>
       <p:sp>
         <p:nvSpPr>
-          <p:cNvPr id="6" name="Text 3"/>
+          <p:cNvPr id="7" name="Text 4"/>
           <p:cNvSpPr txBox="1"/>
           <p:nvPr/>
         </p:nvSpPr>
         <p:spPr>
           <a:xfrm>
-            <a:off x="5760720" y="2011680"/>
+            <a:off x="5760720" y="1965960"/>
             <a:ext cx="2926080" cy="502920"/>
           </a:xfrm>
           <a:prstGeom prst="rect">
@@ -7427,7 +7490,7 @@
               <a:buNone/>
             </a:pPr>
             <a:r>
-              <a:rPr lang="en-US" sz="3000" b="1" dirty="0">
+              <a:rPr lang="en-US" sz="2600" b="1" dirty="0">
                 <a:solidFill>
                   <a:schemeClr val="accent4"/>
                 </a:solidFill>
@@ -7435,21 +7498,21 @@
                 <a:ea typeface="Arial" pitchFamily="34" charset="-122"/>
                 <a:cs typeface="Arial" pitchFamily="34" charset="-120"/>
               </a:rPr>
-              <a:t>± 0</a:t>
+              <a:t>up to 34</a:t>
             </a:r>
-            <a:endParaRPr lang="en-US" sz="3000" dirty="0"/>
-          </a:p>
-        </p:txBody>
-      </p:sp>
-      <p:sp>
-        <p:nvSpPr>
-          <p:cNvPr id="7" name="Text 4"/>
+            <a:endParaRPr lang="en-US" sz="2600" dirty="0"/>
+          </a:p>
+        </p:txBody>
+      </p:sp>
+      <p:sp>
+        <p:nvSpPr>
+          <p:cNvPr id="8" name="Text 5"/>
           <p:cNvSpPr txBox="1"/>
           <p:nvPr/>
         </p:nvSpPr>
         <p:spPr>
           <a:xfrm>
-            <a:off x="5760720" y="2514600"/>
+            <a:off x="5760720" y="2468880"/>
             <a:ext cx="2926080" cy="274320"/>
           </a:xfrm>
           <a:prstGeom prst="rect">
@@ -7471,7 +7534,7 @@
                   <a:schemeClr val="tx1"/>
                 </a:solidFill>
               </a:rPr>
-              <a:t>all other errors (137 → 138)</a:t>
+              <a:t>errors between runs of the SAME config</a:t>
             </a:r>
             <a:endParaRPr lang="en-US" sz="1200" dirty="0"/>
           </a:p>
@@ -7479,14 +7542,14 @@
       </p:sp>
       <p:sp>
         <p:nvSpPr>
-          <p:cNvPr id="8" name="Text 5"/>
+          <p:cNvPr id="9" name="Text 6"/>
           <p:cNvSpPr txBox="1"/>
           <p:nvPr/>
         </p:nvSpPr>
         <p:spPr>
           <a:xfrm>
-            <a:off x="5760720" y="2880360"/>
-            <a:ext cx="2926080" cy="502920"/>
+            <a:off x="5760720" y="2926080"/>
+            <a:ext cx="2926080" cy="274320"/>
           </a:xfrm>
           <a:prstGeom prst="rect">
             <a:avLst/>
@@ -7495,37 +7558,404 @@
           <a:ln/>
         </p:spPr>
         <p:txBody>
-          <a:bodyPr wrap="square" lIns="0" tIns="0" rIns="0" bIns="0" rtlCol="0" anchor="b"/>
+          <a:bodyPr wrap="square" lIns="0" tIns="0" rIns="0" bIns="0" rtlCol="0" anchor="t"/>
           <a:lstStyle/>
           <a:p>
             <a:pPr indent="0" marL="0">
               <a:buNone/>
             </a:pPr>
             <a:r>
-              <a:rPr lang="en-US" sz="3000" b="1" dirty="0">
+              <a:rPr lang="en-US" sz="1200" b="1" dirty="0">
                 <a:solidFill>
-                  <a:schemeClr val="accent1"/>
+                  <a:schemeClr val="tx1"/>
                 </a:solidFill>
-                <a:latin typeface="Arial" pitchFamily="34" charset="0"/>
-                <a:ea typeface="Arial" pitchFamily="34" charset="-122"/>
-                <a:cs typeface="Arial" pitchFamily="34" charset="-120"/>
               </a:rPr>
-              <a:t>94.8 %</a:t>
+              <a:t>Seeds 0–3 per config (pending)</a:t>
             </a:r>
-            <a:endParaRPr lang="en-US" sz="3000" dirty="0"/>
-          </a:p>
-        </p:txBody>
-      </p:sp>
-      <p:sp>
-        <p:nvSpPr>
-          <p:cNvPr id="9" name="Text 6"/>
+            <a:endParaRPr lang="en-US" sz="1200" dirty="0"/>
+          </a:p>
+        </p:txBody>
+      </p:sp>
+      <p:graphicFrame>
+        <p:nvGraphicFramePr>
+          <p:cNvPr id="7" name="Seed results table"/>
+          <p:cNvGraphicFramePr>
+            <a:graphicFrameLocks noGrp="1"/>
+          </p:cNvGraphicFramePr>
+          <p:nvPr>
+            <p:extLst>
+              <p:ext uri="{D42A27DB-BD31-4B8C-83A1-F6EECF244321}">
+                <p14:modId xmlns:p14="http://schemas.microsoft.com/office/powerpoint/2010/main" val="1579011935"/>
+              </p:ext>
+            </p:extLst>
+          </p:nvPr>
+        </p:nvGraphicFramePr>
+        <p:xfrm>
+          <a:off x="5760720" y="3246120"/>
+          <a:ext cx="2926080" cy="914400"/>
+        </p:xfrm>
+        <a:graphic>
+          <a:graphicData uri="http://schemas.openxmlformats.org/drawingml/2006/table">
+            <a:tbl>
+              <a:tblPr/>
+              <a:tblGrid>
+                <a:gridCol w="1188720"/>
+                <a:gridCol w="731520"/>
+                <a:gridCol w="1005840"/>
+              </a:tblGrid>
+              <a:tr h="292608">
+                <a:tc>
+                  <a:txBody>
+                    <a:bodyPr/>
+                    <a:lstStyle/>
+                    <a:p>
+                      <a:pPr indent="0" marL="0">
+                        <a:buNone/>
+                      </a:pPr>
+                      <a:r>
+                        <a:rPr lang="en-US" sz="1100" b="1" dirty="0">
+                          <a:solidFill>
+                            <a:schemeClr val="bg1"/>
+                          </a:solidFill>
+                        </a:rPr>
+                        <a:t>Config</a:t>
+                      </a:r>
+                      <a:endParaRPr lang="en-US" sz="1100" dirty="0"/>
+                    </a:p>
+                  </a:txBody>
+                  <a:tcPr marL="73152" marR="73152" marT="0" marB="0" anchor="ctr">
+                    <a:lnL w="0" cap="flat" cmpd="sng" algn="ctr">
+                      <a:noFill/>
+                    </a:lnL>
+                    <a:lnR w="0" cap="flat" cmpd="sng" algn="ctr">
+                      <a:noFill/>
+                    </a:lnR>
+                    <a:lnT w="0" cap="flat" cmpd="sng" algn="ctr">
+                      <a:noFill/>
+                    </a:lnT>
+                    <a:lnB w="0" cap="flat" cmpd="sng" algn="ctr">
+                      <a:noFill/>
+                    </a:lnB>
+                    <a:solidFill>
+                      <a:schemeClr val="tx2"/>
+                    </a:solidFill>
+                  </a:tcPr>
+                </a:tc>
+                <a:tc>
+                  <a:txBody>
+                    <a:bodyPr/>
+                    <a:lstStyle/>
+                    <a:p>
+                      <a:pPr algn="r" indent="0" marL="0">
+                        <a:buNone/>
+                      </a:pPr>
+                      <a:r>
+                        <a:rPr lang="en-US" sz="1100" b="1" dirty="0">
+                          <a:solidFill>
+                            <a:schemeClr val="bg1"/>
+                          </a:solidFill>
+                        </a:rPr>
+                        <a:t>Top-1</a:t>
+                      </a:r>
+                      <a:endParaRPr lang="en-US" sz="1100" dirty="0"/>
+                    </a:p>
+                  </a:txBody>
+                  <a:tcPr marL="73152" marR="73152" marT="0" marB="0" anchor="ctr">
+                    <a:lnL w="0" cap="flat" cmpd="sng" algn="ctr">
+                      <a:noFill/>
+                    </a:lnL>
+                    <a:lnR w="0" cap="flat" cmpd="sng" algn="ctr">
+                      <a:noFill/>
+                    </a:lnR>
+                    <a:lnT w="0" cap="flat" cmpd="sng" algn="ctr">
+                      <a:noFill/>
+                    </a:lnT>
+                    <a:lnB w="0" cap="flat" cmpd="sng" algn="ctr">
+                      <a:noFill/>
+                    </a:lnB>
+                    <a:solidFill>
+                      <a:schemeClr val="tx2"/>
+                    </a:solidFill>
+                  </a:tcPr>
+                </a:tc>
+                <a:tc>
+                  <a:txBody>
+                    <a:bodyPr/>
+                    <a:lstStyle/>
+                    <a:p>
+                      <a:pPr algn="r" indent="0" marL="0">
+                        <a:buNone/>
+                      </a:pPr>
+                      <a:r>
+                        <a:rPr lang="en-US" sz="1100" b="1" dirty="0">
+                          <a:solidFill>
+                            <a:schemeClr val="bg1"/>
+                          </a:solidFill>
+                        </a:rPr>
+                        <a:t>Length err.</a:t>
+                      </a:r>
+                      <a:endParaRPr lang="en-US" sz="1100" dirty="0"/>
+                    </a:p>
+                  </a:txBody>
+                  <a:tcPr marL="73152" marR="73152" marT="0" marB="0" anchor="ctr">
+                    <a:lnL w="0" cap="flat" cmpd="sng" algn="ctr">
+                      <a:noFill/>
+                    </a:lnL>
+                    <a:lnR w="0" cap="flat" cmpd="sng" algn="ctr">
+                      <a:noFill/>
+                    </a:lnR>
+                    <a:lnT w="0" cap="flat" cmpd="sng" algn="ctr">
+                      <a:noFill/>
+                    </a:lnT>
+                    <a:lnB w="0" cap="flat" cmpd="sng" algn="ctr">
+                      <a:noFill/>
+                    </a:lnB>
+                    <a:solidFill>
+                      <a:schemeClr val="tx2"/>
+                    </a:solidFill>
+                  </a:tcPr>
+                </a:tc>
+              </a:tr>
+              <a:tr h="292608">
+                <a:tc>
+                  <a:txBody>
+                    <a:bodyPr/>
+                    <a:lstStyle/>
+                    <a:p>
+                      <a:pPr indent="0" marL="0">
+                        <a:buNone/>
+                      </a:pPr>
+                      <a:r>
+                        <a:rPr lang="en-US" sz="1100" dirty="0">
+                          <a:solidFill>
+                            <a:schemeClr val="tx1"/>
+                          </a:solidFill>
+                        </a:rPr>
+                        <a:t>Baseline</a:t>
+                      </a:r>
+                      <a:endParaRPr lang="en-US" sz="1100" dirty="0"/>
+                    </a:p>
+                  </a:txBody>
+                  <a:tcPr marL="73152" marR="73152" marT="0" marB="0" anchor="ctr">
+                    <a:lnL w="0" cap="flat" cmpd="sng" algn="ctr">
+                      <a:noFill/>
+                    </a:lnL>
+                    <a:lnR w="0" cap="flat" cmpd="sng" algn="ctr">
+                      <a:noFill/>
+                    </a:lnR>
+                    <a:lnT w="0" cap="flat" cmpd="sng" algn="ctr">
+                      <a:noFill/>
+                    </a:lnT>
+                    <a:lnB w="0" cap="flat" cmpd="sng" algn="ctr">
+                      <a:noFill/>
+                    </a:lnB>
+                    <a:solidFill>
+                      <a:schemeClr val="bg2"/>
+                    </a:solidFill>
+                  </a:tcPr>
+                </a:tc>
+                <a:tc>
+                  <a:txBody>
+                    <a:bodyPr/>
+                    <a:lstStyle/>
+                    <a:p>
+                      <a:pPr algn="r" indent="0" marL="0">
+                        <a:buNone/>
+                      </a:pPr>
+                      <a:r>
+                        <a:rPr lang="en-US" sz="1100" dirty="0">
+                          <a:solidFill>
+                            <a:schemeClr val="tx1"/>
+                          </a:solidFill>
+                        </a:rPr>
+                        <a:t>tbd</a:t>
+                      </a:r>
+                      <a:endParaRPr lang="en-US" sz="1100" dirty="0"/>
+                    </a:p>
+                  </a:txBody>
+                  <a:tcPr marL="73152" marR="73152" marT="0" marB="0" anchor="ctr">
+                    <a:lnL w="0" cap="flat" cmpd="sng" algn="ctr">
+                      <a:noFill/>
+                    </a:lnL>
+                    <a:lnR w="0" cap="flat" cmpd="sng" algn="ctr">
+                      <a:noFill/>
+                    </a:lnR>
+                    <a:lnT w="0" cap="flat" cmpd="sng" algn="ctr">
+                      <a:noFill/>
+                    </a:lnT>
+                    <a:lnB w="0" cap="flat" cmpd="sng" algn="ctr">
+                      <a:noFill/>
+                    </a:lnB>
+                    <a:solidFill>
+                      <a:schemeClr val="bg2"/>
+                    </a:solidFill>
+                  </a:tcPr>
+                </a:tc>
+                <a:tc>
+                  <a:txBody>
+                    <a:bodyPr/>
+                    <a:lstStyle/>
+                    <a:p>
+                      <a:pPr algn="r" indent="0" marL="0">
+                        <a:buNone/>
+                      </a:pPr>
+                      <a:r>
+                        <a:rPr lang="en-US" sz="1100" dirty="0">
+                          <a:solidFill>
+                            <a:schemeClr val="tx1"/>
+                          </a:solidFill>
+                        </a:rPr>
+                        <a:t>tbd</a:t>
+                      </a:r>
+                      <a:endParaRPr lang="en-US" sz="1100" dirty="0"/>
+                    </a:p>
+                  </a:txBody>
+                  <a:tcPr marL="73152" marR="73152" marT="0" marB="0" anchor="ctr">
+                    <a:lnL w="0" cap="flat" cmpd="sng" algn="ctr">
+                      <a:noFill/>
+                    </a:lnL>
+                    <a:lnR w="0" cap="flat" cmpd="sng" algn="ctr">
+                      <a:noFill/>
+                    </a:lnR>
+                    <a:lnT w="0" cap="flat" cmpd="sng" algn="ctr">
+                      <a:noFill/>
+                    </a:lnT>
+                    <a:lnB w="0" cap="flat" cmpd="sng" algn="ctr">
+                      <a:noFill/>
+                    </a:lnB>
+                    <a:solidFill>
+                      <a:schemeClr val="bg2"/>
+                    </a:solidFill>
+                  </a:tcPr>
+                </a:tc>
+              </a:tr>
+              <a:tr h="292608">
+                <a:tc>
+                  <a:txBody>
+                    <a:bodyPr/>
+                    <a:lstStyle/>
+                    <a:p>
+                      <a:pPr indent="0" marL="0">
+                        <a:buNone/>
+                      </a:pPr>
+                      <a:r>
+                        <a:rPr lang="en-US" sz="1100" dirty="0">
+                          <a:solidFill>
+                            <a:schemeClr val="tx1"/>
+                          </a:solidFill>
+                        </a:rPr>
+                        <a:t>With size</a:t>
+                      </a:r>
+                      <a:endParaRPr lang="en-US" sz="1100" dirty="0"/>
+                    </a:p>
+                  </a:txBody>
+                  <a:tcPr marL="73152" marR="73152" marT="0" marB="0" anchor="ctr">
+                    <a:lnL w="0" cap="flat" cmpd="sng" algn="ctr">
+                      <a:noFill/>
+                    </a:lnL>
+                    <a:lnR w="0" cap="flat" cmpd="sng" algn="ctr">
+                      <a:noFill/>
+                    </a:lnR>
+                    <a:lnT w="0" cap="flat" cmpd="sng" algn="ctr">
+                      <a:noFill/>
+                    </a:lnT>
+                    <a:lnB w="0" cap="flat" cmpd="sng" algn="ctr">
+                      <a:noFill/>
+                    </a:lnB>
+                    <a:solidFill>
+                      <a:schemeClr val="bg2"/>
+                    </a:solidFill>
+                  </a:tcPr>
+                </a:tc>
+                <a:tc>
+                  <a:txBody>
+                    <a:bodyPr/>
+                    <a:lstStyle/>
+                    <a:p>
+                      <a:pPr algn="r" indent="0" marL="0">
+                        <a:buNone/>
+                      </a:pPr>
+                      <a:r>
+                        <a:rPr lang="en-US" sz="1100" dirty="0">
+                          <a:solidFill>
+                            <a:schemeClr val="tx1"/>
+                          </a:solidFill>
+                        </a:rPr>
+                        <a:t>tbd</a:t>
+                      </a:r>
+                      <a:endParaRPr lang="en-US" sz="1100" dirty="0"/>
+                    </a:p>
+                  </a:txBody>
+                  <a:tcPr marL="73152" marR="73152" marT="0" marB="0" anchor="ctr">
+                    <a:lnL w="0" cap="flat" cmpd="sng" algn="ctr">
+                      <a:noFill/>
+                    </a:lnL>
+                    <a:lnR w="0" cap="flat" cmpd="sng" algn="ctr">
+                      <a:noFill/>
+                    </a:lnR>
+                    <a:lnT w="0" cap="flat" cmpd="sng" algn="ctr">
+                      <a:noFill/>
+                    </a:lnT>
+                    <a:lnB w="0" cap="flat" cmpd="sng" algn="ctr">
+                      <a:noFill/>
+                    </a:lnB>
+                    <a:solidFill>
+                      <a:schemeClr val="bg2"/>
+                    </a:solidFill>
+                  </a:tcPr>
+                </a:tc>
+                <a:tc>
+                  <a:txBody>
+                    <a:bodyPr/>
+                    <a:lstStyle/>
+                    <a:p>
+                      <a:pPr algn="r" indent="0" marL="0">
+                        <a:buNone/>
+                      </a:pPr>
+                      <a:r>
+                        <a:rPr lang="en-US" sz="1100" dirty="0">
+                          <a:solidFill>
+                            <a:schemeClr val="tx1"/>
+                          </a:solidFill>
+                        </a:rPr>
+                        <a:t>tbd</a:t>
+                      </a:r>
+                      <a:endParaRPr lang="en-US" sz="1100" dirty="0"/>
+                    </a:p>
+                  </a:txBody>
+                  <a:tcPr marL="73152" marR="73152" marT="0" marB="0" anchor="ctr">
+                    <a:lnL w="0" cap="flat" cmpd="sng" algn="ctr">
+                      <a:noFill/>
+                    </a:lnL>
+                    <a:lnR w="0" cap="flat" cmpd="sng" algn="ctr">
+                      <a:noFill/>
+                    </a:lnR>
+                    <a:lnT w="0" cap="flat" cmpd="sng" algn="ctr">
+                      <a:noFill/>
+                    </a:lnT>
+                    <a:lnB w="0" cap="flat" cmpd="sng" algn="ctr">
+                      <a:noFill/>
+                    </a:lnB>
+                    <a:solidFill>
+                      <a:schemeClr val="bg2"/>
+                    </a:solidFill>
+                  </a:tcPr>
+                </a:tc>
+              </a:tr>
+            </a:tbl>
+          </a:graphicData>
+        </a:graphic>
+      </p:graphicFrame>
+      <p:sp>
+        <p:nvSpPr>
+          <p:cNvPr id="11" name="Text 7"/>
           <p:cNvSpPr txBox="1"/>
           <p:nvPr/>
         </p:nvSpPr>
         <p:spPr>
           <a:xfrm>
-            <a:off x="5760720" y="3383280"/>
-            <a:ext cx="2926080" cy="274320"/>
+            <a:off x="5760720" y="4206240"/>
+            <a:ext cx="2926080" cy="320040"/>
           </a:xfrm>
           <a:prstGeom prst="rect">
             <a:avLst/>
@@ -7541,79 +7971,14 @@
               <a:buNone/>
             </a:pPr>
             <a:r>
-              <a:rPr lang="en-US" sz="1200" dirty="0">
+              <a:rPr lang="en-US" sz="1000" i="1" dirty="0">
                 <a:solidFill>
-                  <a:schemeClr val="tx1"/>
+                  <a:schemeClr val="accent4"/>
                 </a:solidFill>
               </a:rPr>
-              <a:t>top-1 overall (was 93.7 %)</a:t>
+              <a:t>Mean ± range, to be filled in after the seed runs.</a:t>
             </a:r>
-            <a:endParaRPr lang="en-US" sz="1200" dirty="0"/>
-          </a:p>
-        </p:txBody>
-      </p:sp>
-      <p:sp>
-        <p:nvSpPr>
-          <p:cNvPr id="10" name="Seed caveat card"/>
-          <p:cNvSpPr/>
-          <p:nvPr/>
-        </p:nvSpPr>
-        <p:spPr>
-          <a:xfrm>
-            <a:off x="5760720" y="3840480"/>
-            <a:ext cx="2926080" cy="685800"/>
-          </a:xfrm>
-          <a:prstGeom prst="roundRect">
-            <a:avLst>
-              <a:gd name="adj" fmla="val 10667"/>
-            </a:avLst>
-          </a:prstGeom>
-          <a:solidFill>
-            <a:schemeClr val="bg2"/>
-          </a:solidFill>
-          <a:ln w="12700">
-            <a:solidFill>
-              <a:schemeClr val="bg2">
-                <a:alpha val="0"/>
-              </a:schemeClr>
-            </a:solidFill>
-            <a:prstDash val="solid"/>
-          </a:ln>
-        </p:spPr>
-      </p:sp>
-      <p:sp>
-        <p:nvSpPr>
-          <p:cNvPr id="11" name="Text 8"/>
-          <p:cNvSpPr txBox="1"/>
-          <p:nvPr/>
-        </p:nvSpPr>
-        <p:spPr>
-          <a:xfrm>
-            <a:off x="5897880" y="3886200"/>
-            <a:ext cx="2697480" cy="594360"/>
-          </a:xfrm>
-          <a:prstGeom prst="rect">
-            <a:avLst/>
-          </a:prstGeom>
-          <a:noFill/>
-          <a:ln/>
-        </p:spPr>
-        <p:txBody>
-          <a:bodyPr wrap="square" lIns="0" tIns="0" rIns="0" bIns="0" rtlCol="0" anchor="ctr"/>
-          <a:lstStyle/>
-          <a:p>
-            <a:pPr indent="0" marL="0">
-              <a:buNone/>
-            </a:pPr>
-            <a:r>
-              <a:rPr lang="en-US" sz="1100" i="1" dirty="0">
-                <a:solidFill>
-                  <a:schemeClr val="tx1"/>
-                </a:solidFill>
-              </a:rPr>
-              <a:t>One run per variant so far – more seeds before we call it final.</a:t>
-            </a:r>
-            <a:endParaRPr lang="en-US" sz="1100" dirty="0"/>
+            <a:endParaRPr lang="en-US" sz="1000" dirty="0"/>
           </a:p>
         </p:txBody>
       </p:sp>
@@ -8463,7 +8828,7 @@
                   <a:schemeClr val="bg1"/>
                 </a:solidFill>
               </a:rPr>
-              <a:t>Three seeds per variant before we report the size effect as final.</a:t>
+              <a:t>Runs of the same config differ by up to 34 errors: always several seeds.</a:t>
             </a:r>
             <a:endParaRPr lang="en-US" sz="1300" dirty="0"/>
           </a:p>

</xml_diff>